<commit_message>
docs: align presentation slides with docs and modern asynchronous architecture
</commit_message>
<xml_diff>
--- a/EvalixAI_Major_Project_Final.pptx
+++ b/EvalixAI_Major_Project_Final.pptx
@@ -19780,6 +19780,33 @@
                 <a:cs typeface="Times New Roman"/>
                 <a:sym typeface="Times New Roman"/>
               </a:rPr>
+              <a:t>System Benchmarks: </a:t>
+            </a:r>
+            <a:r>
+              <a:rPr lang="en-US" sz="1400">
+                <a:solidFill>
+                  <a:srgbClr val="1E293B"/>
+                </a:solidFill>
+                <a:latin typeface="Times New Roman"/>
+              </a:rPr>
+              <a:t>REST API P50 &lt; 40ms, P95 &lt; 150ms; Qdrant vector search &lt; 25ms (100k profiles); FCP &lt; 1.2s; Resume parsing (&gt;= 50 docs/min).</a:t>
+            </a:r>
+          </a:p>
+          <a:p>
+            <a:pPr indent="-401638" lvl="0" marL="519113" rtl="0" algn="l">
+              <a:lnSpc>
+                <a:spcPct val="115000"/>
+              </a:lnSpc>
+              <a:buSzPts val="1200"/>
+              <a:buChar char="⚫"/>
+            </a:pPr>
+            <a:r>
+              <a:rPr b="1" lang="en-US" sz="1400">
+                <a:solidFill>
+                  <a:srgbClr val="0F172A"/>
+                </a:solidFill>
+                <a:latin typeface="Times New Roman"/>
+              </a:rPr>
               <a:t>Conclusion: </a:t>
             </a:r>
             <a:r>
@@ -19886,7 +19913,7 @@
             </a:pPr>
             <a:r>
               <a:rPr lang="en-US"/>
-              <a:t>8/10/2026</a:t>
+              <a:t>September 2026</a:t>
             </a:r>
             <a:endParaRPr/>
           </a:p>
@@ -20372,7 +20399,7 @@
             </a:pPr>
             <a:r>
               <a:rPr lang="en-US"/>
-              <a:t>8/10/2026</a:t>
+              <a:t>September 2026</a:t>
             </a:r>
             <a:endParaRPr/>
           </a:p>
@@ -20795,7 +20822,7 @@
             </a:pPr>
             <a:r>
               <a:rPr lang="en-US"/>
-              <a:t>8/10/2026</a:t>
+              <a:t>September 2026</a:t>
             </a:r>
             <a:endParaRPr/>
           </a:p>
@@ -20854,7 +20881,7 @@
 </file>
 
 <file path=ppt/slides/slide4.xml><?xml version="1.0" encoding="utf-8"?>
-<p:sld xmlns:a="http://schemas.openxmlformats.org/drawingml/2006/main" xmlns:r="http://schemas.openxmlformats.org/officeDocument/2006/relationships" xmlns:mc="http://schemas.openxmlformats.org/markup-compatibility/2006" xmlns:mv="urn:schemas-microsoft-com:mac:vml" xmlns:p="http://schemas.openxmlformats.org/presentationml/2006/main" xmlns:c="http://schemas.openxmlformats.org/drawingml/2006/chart" xmlns:dgm="http://schemas.openxmlformats.org/drawingml/2006/diagram" xmlns:o="urn:schemas-microsoft-com:office:office" xmlns:v="urn:schemas-microsoft-com:vml" xmlns:pvml="urn:schemas-microsoft-com:office:powerpoint" xmlns:com="http://schemas.openxmlformats.org/drawingml/2006/compatibility" xmlns:p14="http://schemas.microsoft.com/office/powerpoint/2010/main" xmlns:p15="http://schemas.microsoft.com/office/powerpoint/2012/main" xmlns:ahyp="http://schemas.microsoft.com/office/drawing/2018/hyperlinkcolor">
+<p:sld xmlns:a="http://schemas.openxmlformats.org/drawingml/2006/main" xmlns:p="http://schemas.openxmlformats.org/presentationml/2006/main">
   <p:cSld>
     <p:spTree>
       <p:nvGrpSpPr>
@@ -21330,7 +21357,7 @@
                 <a:cs typeface="Times New Roman"/>
                 <a:sym typeface="Times New Roman"/>
               </a:rPr>
-              <a:t>Cloud-native microservices architecture designed specifically for startup budgets.</a:t>
+              <a:t>Cloud-native asynchronous architecture designed specifically for startup budgets.</a:t>
             </a:r>
             <a:endParaRPr>
               <a:latin typeface="Times New Roman"/>
@@ -21379,7 +21406,7 @@
             </a:pPr>
             <a:r>
               <a:rPr lang="en-US"/>
-              <a:t>8/10/2026</a:t>
+              <a:t>September 2026</a:t>
             </a:r>
             <a:endParaRPr/>
           </a:p>
@@ -22152,7 +22179,7 @@
 </file>
 
 <file path=ppt/slides/slide5.xml><?xml version="1.0" encoding="utf-8"?>
-<p:sld xmlns:a="http://schemas.openxmlformats.org/drawingml/2006/main" xmlns:r="http://schemas.openxmlformats.org/officeDocument/2006/relationships" xmlns:mc="http://schemas.openxmlformats.org/markup-compatibility/2006" xmlns:mv="urn:schemas-microsoft-com:mac:vml" xmlns:p="http://schemas.openxmlformats.org/presentationml/2006/main" xmlns:c="http://schemas.openxmlformats.org/drawingml/2006/chart" xmlns:dgm="http://schemas.openxmlformats.org/drawingml/2006/diagram" xmlns:o="urn:schemas-microsoft-com:office:office" xmlns:v="urn:schemas-microsoft-com:vml" xmlns:pvml="urn:schemas-microsoft-com:office:powerpoint" xmlns:com="http://schemas.openxmlformats.org/drawingml/2006/compatibility" xmlns:p14="http://schemas.microsoft.com/office/powerpoint/2010/main" xmlns:p15="http://schemas.microsoft.com/office/powerpoint/2012/main" xmlns:ahyp="http://schemas.microsoft.com/office/drawing/2018/hyperlinkcolor">
+<p:sld xmlns:a="http://schemas.openxmlformats.org/drawingml/2006/main" xmlns:p="http://schemas.openxmlformats.org/presentationml/2006/main">
   <p:cSld>
     <p:spTree>
       <p:nvGrpSpPr>
@@ -22287,7 +22314,7 @@
                 <a:cs typeface="Times New Roman"/>
                 <a:sym typeface="Times New Roman"/>
               </a:rPr>
-              <a:t>PDF/DOCX ingestion, structured JSON entity extraction, qualification gap analysis, and Claude LLM semantic scoring (FR-1.1–FR-1.11).</a:t>
+              <a:t>PDF/DOCX ingestion, structured JSON extraction, Qdrant vector search (HNSW cosine metric), and Claude LLM semantic gap analysis (FR-1.1–FR-1.11).</a:t>
             </a:r>
             <a:endParaRPr>
               <a:latin typeface="Times New Roman"/>
@@ -22909,7 +22936,7 @@
 </file>
 
 <file path=ppt/slides/slide6.xml><?xml version="1.0" encoding="utf-8"?>
-<p:sld xmlns:a="http://schemas.openxmlformats.org/drawingml/2006/main" xmlns:r="http://schemas.openxmlformats.org/officeDocument/2006/relationships" xmlns:mc="http://schemas.openxmlformats.org/markup-compatibility/2006" xmlns:mv="urn:schemas-microsoft-com:mac:vml" xmlns:p="http://schemas.openxmlformats.org/presentationml/2006/main" xmlns:c="http://schemas.openxmlformats.org/drawingml/2006/chart" xmlns:dgm="http://schemas.openxmlformats.org/drawingml/2006/diagram" xmlns:o="urn:schemas-microsoft-com:office:office" xmlns:v="urn:schemas-microsoft-com:vml" xmlns:pvml="urn:schemas-microsoft-com:office:powerpoint" xmlns:com="http://schemas.openxmlformats.org/drawingml/2006/compatibility" xmlns:p14="http://schemas.microsoft.com/office/powerpoint/2010/main" xmlns:p15="http://schemas.microsoft.com/office/powerpoint/2012/main" xmlns:ahyp="http://schemas.microsoft.com/office/drawing/2018/hyperlinkcolor">
+<p:sld xmlns:a="http://schemas.openxmlformats.org/drawingml/2006/main" xmlns:p="http://schemas.openxmlformats.org/presentationml/2006/main">
   <p:cSld>
     <p:spTree>
       <p:nvGrpSpPr>
@@ -23044,7 +23071,7 @@
                 <a:cs typeface="Times New Roman"/>
                 <a:sym typeface="Times New Roman"/>
               </a:rPr>
-              <a:t>Next.js</a:t>
+              <a:t>Next.js 16 (React 19</a:t>
             </a:r>
             <a:r>
               <a:rPr lang="en-US" sz="1500">
@@ -23056,7 +23083,7 @@
                 <a:cs typeface="Times New Roman"/>
                 <a:sym typeface="Times New Roman"/>
               </a:rPr>
-              <a:t> (App Router), React</a:t>
+              <a:t>, App Router, Tailwind CSS, Radix UI)</a:t>
             </a:r>
             <a:endParaRPr>
               <a:latin typeface="Times New Roman"/>
@@ -23089,7 +23116,7 @@
                 <a:cs typeface="Times New Roman"/>
                 <a:sym typeface="Times New Roman"/>
               </a:rPr>
-              <a:t>Backend &amp; Microservices: </a:t>
+              <a:t>Backend &amp; API Layer: </a:t>
             </a:r>
             <a:r>
               <a:rPr lang="en-US" sz="1500">
@@ -23101,7 +23128,7 @@
                 <a:cs typeface="Times New Roman"/>
                 <a:sym typeface="Times New Roman"/>
               </a:rPr>
-              <a:t>Python FastAPI (AI Services), Prisma ORM</a:t>
+              <a:t>Python 3.12 FastAPI 0.115 ASGI, Uvicorn, Pydantic v2</a:t>
             </a:r>
             <a:endParaRPr>
               <a:latin typeface="Times New Roman"/>
@@ -23134,7 +23161,7 @@
                 <a:cs typeface="Times New Roman"/>
                 <a:sym typeface="Times New Roman"/>
               </a:rPr>
-              <a:t>Database &amp; Caching: </a:t>
+              <a:t>Persistence &amp; Vector: </a:t>
             </a:r>
             <a:r>
               <a:rPr lang="en-US" sz="1500">
@@ -23146,7 +23173,7 @@
                 <a:cs typeface="Times New Roman"/>
                 <a:sym typeface="Times New Roman"/>
               </a:rPr>
-              <a:t>PostgreSQL(Relational RDS), Redis (In-Memory Session Caching &amp; Task Queues)</a:t>
+              <a:t>MongoDB 7 (Motor Async), Qdrant v1.12+ (HNSW Cosine Vector Search)</a:t>
             </a:r>
             <a:endParaRPr>
               <a:latin typeface="Times New Roman"/>
@@ -23191,7 +23218,7 @@
                 <a:cs typeface="Times New Roman"/>
                 <a:sym typeface="Times New Roman"/>
               </a:rPr>
-              <a:t>Minio</a:t>
+              <a:t>SeaweedFS / S3 API</a:t>
             </a:r>
             <a:r>
               <a:rPr lang="en-US" sz="1500">
@@ -23203,7 +23230,7 @@
                 <a:cs typeface="Times New Roman"/>
                 <a:sym typeface="Times New Roman"/>
               </a:rPr>
-              <a:t>(Object Storage), Anthropic Claude API (Claude Sonnet / Haiku)</a:t>
+              <a:t>, Anthropic Claude &amp; OpenAI APIs</a:t>
             </a:r>
             <a:endParaRPr>
               <a:latin typeface="Times New Roman"/>
@@ -23236,7 +23263,7 @@
                 <a:cs typeface="Times New Roman"/>
                 <a:sym typeface="Times New Roman"/>
               </a:rPr>
-              <a:t>Code Execution Engine: </a:t>
+              <a:t>Sandbox &amp; In-Memory: </a:t>
             </a:r>
             <a:r>
               <a:rPr lang="en-US" sz="1500">
@@ -23248,7 +23275,7 @@
                 <a:cs typeface="Times New Roman"/>
                 <a:sym typeface="Times New Roman"/>
               </a:rPr>
-              <a:t>Judge0 API</a:t>
+              <a:t>Judge0 / Docker Runner (2s/256MB), Redis 7 (Sessions &amp; Limits)</a:t>
             </a:r>
             <a:endParaRPr>
               <a:latin typeface="Times New Roman"/>
@@ -23281,7 +23308,7 @@
                 <a:cs typeface="Times New Roman"/>
                 <a:sym typeface="Times New Roman"/>
               </a:rPr>
-              <a:t>DevOps &amp; Ingress: </a:t>
+              <a:t>DevOps &amp; Media: </a:t>
             </a:r>
             <a:r>
               <a:rPr lang="en-US" sz="1500">
@@ -23293,7 +23320,7 @@
                 <a:cs typeface="Times New Roman"/>
                 <a:sym typeface="Times New Roman"/>
               </a:rPr>
-              <a:t>Docker</a:t>
+              <a:t>Docker Compose Multi-Service Bridges, Browser WebRTC</a:t>
             </a:r>
             <a:endParaRPr>
               <a:latin typeface="Times New Roman"/>
@@ -23338,7 +23365,7 @@
                 <a:cs typeface="Times New Roman"/>
                 <a:sym typeface="Times New Roman"/>
               </a:rPr>
-              <a:t>OAuth 2</a:t>
+              <a:t>Bcrypt (&gt;= 12), PyJWT Cookies (evalix_at)</a:t>
             </a:r>
             <a:r>
               <a:rPr lang="en-US" sz="1500">
@@ -23350,7 +23377,7 @@
                 <a:cs typeface="Times New Roman"/>
                 <a:sym typeface="Times New Roman"/>
               </a:rPr>
-              <a:t>.0 </a:t>
+              <a:t> &amp; Token Rotation</a:t>
             </a:r>
             <a:endParaRPr>
               <a:latin typeface="Times New Roman"/>
@@ -23932,7 +23959,7 @@
 </file>
 
 <file path=ppt/slides/slide7.xml><?xml version="1.0" encoding="utf-8"?>
-<p:sld xmlns:a="http://schemas.openxmlformats.org/drawingml/2006/main" xmlns:r="http://schemas.openxmlformats.org/officeDocument/2006/relationships" xmlns:mc="http://schemas.openxmlformats.org/markup-compatibility/2006" xmlns:mv="urn:schemas-microsoft-com:mac:vml" xmlns:p="http://schemas.openxmlformats.org/presentationml/2006/main" xmlns:c="http://schemas.openxmlformats.org/drawingml/2006/chart" xmlns:dgm="http://schemas.openxmlformats.org/drawingml/2006/diagram" xmlns:o="urn:schemas-microsoft-com:office:office" xmlns:v="urn:schemas-microsoft-com:vml" xmlns:pvml="urn:schemas-microsoft-com:office:powerpoint" xmlns:com="http://schemas.openxmlformats.org/drawingml/2006/compatibility" xmlns:p14="http://schemas.microsoft.com/office/powerpoint/2010/main" xmlns:p15="http://schemas.microsoft.com/office/powerpoint/2012/main" xmlns:ahyp="http://schemas.microsoft.com/office/drawing/2018/hyperlinkcolor">
+<p:sld xmlns:a="http://schemas.openxmlformats.org/drawingml/2006/main" xmlns:p="http://schemas.openxmlformats.org/presentationml/2006/main">
   <p:cSld>
     <p:spTree>
       <p:nvGrpSpPr>
@@ -24090,7 +24117,7 @@
                 <a:cs typeface="Times New Roman"/>
                 <a:sym typeface="Times New Roman"/>
               </a:rPr>
-              <a:t>• PostgreSQL schema &amp; Prisma ORM setup | OAuth 2.0 / JWT integration</a:t>
+              <a:t>• FastAPI &amp; Next.js 16 scaffold | MongoDB 7 &amp; Motor async models (ADR-001)</a:t>
             </a:r>
             <a:br>
               <a:rPr lang="en-US" sz="1350">
@@ -24113,7 +24140,7 @@
                 <a:cs typeface="Times New Roman"/>
                 <a:sym typeface="Times New Roman"/>
               </a:rPr>
-              <a:t>• minio document ingestion pipeline | Claude LLM semantic parser &amp; scoring</a:t>
+              <a:t>• SeaweedFS S3 upload presigning | Qdrant vector engine &amp; Claude semantic screening (ADR-002, ADR-003)</a:t>
             </a:r>
             <a:br>
               <a:rPr lang="en-US" sz="1350">
@@ -24136,7 +24163,7 @@
                 <a:cs typeface="Times New Roman"/>
                 <a:sym typeface="Times New Roman"/>
               </a:rPr>
-              <a:t>• Engineering: Aakash (Auth/minio) | Manish (Schema/Claude API)</a:t>
+              <a:t>• Engineering: Aakash (Dashboard UI/Auth) | Manish (FastAPI/MongoDB/Qdrant)</a:t>
             </a:r>
             <a:endParaRPr>
               <a:latin typeface="Times New Roman"/>
@@ -24456,7 +24483,7 @@
                 <a:cs typeface="Times New Roman"/>
                 <a:sym typeface="Times New Roman"/>
               </a:rPr>
-              <a:t>• Recruiter &amp; candidate workflow integration | SendGrid automated email notifications</a:t>
+              <a:t>• Recruiter &amp; candidate portal integration | SendGrid transactional notifications</a:t>
             </a:r>
             <a:br>
               <a:rPr lang="en-US" sz="1350">
@@ -24479,7 +24506,7 @@
                 <a:cs typeface="Times New Roman"/>
                 <a:sym typeface="Times New Roman"/>
               </a:rPr>
-              <a:t>• Load testing (1,000 concurrent sessions) | Kubernetes / NGINX Ingress cloud deployment</a:t>
+              <a:t>• Load testing (5,000 concurrent sessions) | Docker Compose multi-service orchestration with health checks</a:t>
             </a:r>
             <a:br>
               <a:rPr lang="en-US" sz="1350">
@@ -24502,7 +24529,7 @@
                 <a:cs typeface="Times New Roman"/>
                 <a:sym typeface="Times New Roman"/>
               </a:rPr>
-              <a:t>• Engineering: Aakash (Workflow/WCAG) | Manish (K8s/Load Testing)</a:t>
+              <a:t>• Engineering: Aakash (Candidate Portal/WCAG) | Manish (Docker Orchestration/Load Testing)</a:t>
             </a:r>
             <a:endParaRPr>
               <a:latin typeface="Times New Roman"/>
@@ -24551,7 +24578,7 @@
             </a:pPr>
             <a:r>
               <a:rPr lang="en-US"/>
-              <a:t>8/10/2026</a:t>
+              <a:t>September 2026</a:t>
             </a:r>
             <a:endParaRPr/>
           </a:p>
@@ -25248,7 +25275,7 @@
 </file>
 
 <file path=ppt/slides/slide8.xml><?xml version="1.0" encoding="utf-8"?>
-<p:sld xmlns:a="http://schemas.openxmlformats.org/drawingml/2006/main" xmlns:r="http://schemas.openxmlformats.org/officeDocument/2006/relationships" xmlns:mc="http://schemas.openxmlformats.org/markup-compatibility/2006" xmlns:mv="urn:schemas-microsoft-com:mac:vml" xmlns:p="http://schemas.openxmlformats.org/presentationml/2006/main" xmlns:c="http://schemas.openxmlformats.org/drawingml/2006/chart" xmlns:dgm="http://schemas.openxmlformats.org/drawingml/2006/diagram" xmlns:o="urn:schemas-microsoft-com:office:office" xmlns:v="urn:schemas-microsoft-com:vml" xmlns:pvml="urn:schemas-microsoft-com:office:powerpoint" xmlns:com="http://schemas.openxmlformats.org/drawingml/2006/compatibility" xmlns:p14="http://schemas.microsoft.com/office/powerpoint/2010/main" xmlns:p15="http://schemas.microsoft.com/office/powerpoint/2012/main" xmlns:ahyp="http://schemas.microsoft.com/office/drawing/2018/hyperlinkcolor">
+<p:sld xmlns:a="http://schemas.openxmlformats.org/drawingml/2006/main" xmlns:p="http://schemas.openxmlformats.org/presentationml/2006/main" xmlns:r="http://schemas.openxmlformats.org/officeDocument/2006/relationships">
   <p:cSld>
     <p:spTree>
       <p:nvGrpSpPr>
@@ -25310,7 +25337,7 @@
                 <a:cs typeface="Times New Roman"/>
                 <a:sym typeface="Times New Roman"/>
               </a:rPr>
-              <a:t>System Architecture &amp; Microservices Topology</a:t>
+              <a:t>System Architecture &amp; Multi-Tier Cloud Topology</a:t>
             </a:r>
             <a:endParaRPr>
               <a:latin typeface="Times New Roman"/>
@@ -25468,7 +25495,7 @@
             </a:pPr>
             <a:r>
               <a:rPr lang="en-US"/>
-              <a:t>8/10/2026</a:t>
+              <a:t>September 2026</a:t>
             </a:r>
             <a:endParaRPr/>
           </a:p>

</xml_diff>